<commit_message>
Static final-state mode (--static) with print/PDF decks for U2 S2.3 and S2.4; S2.4 fixes
Co-Authored-By: Claude Sonnet 5.5 <noreply@anthropic.com>
Claude-Session: https://claude.ai/code/session_01CAqidLLu6PiYNMcZx5qMsE
</commit_message>
<xml_diff>
--- a/deliverables/chem-u02/SHULL_CHEM_Slides_U02_S02.4.pptx
+++ b/deliverables/chem-u02/SHULL_CHEM_Slides_U02_S02.4.pptx
@@ -523,7 +523,7 @@
           <a:p>
             <a:r>
               <a:rPr lang="en-US" dirty="0"/>
-              <a:t>Section title. PROVISIONAL/OPEN: verbatim DECISIONS title now in the panel (see build report for fit). Scope boundary (Matt, 2026-10-04): S2.4 owns what an ion's configuration IS and valence-electron-based charge prediction at the end of the section (main group only). U3.7 and U3.4 own the energetics. PROVISIONAL: group 14 and transition metals are not predicted by the rule here. Not taught here: Lewis dot preview (PROVISIONAL, omitted; belongs to a later unit). Transition-metal valence counting (PROVISIONAL, brief slide 6) also omitted. Image slot empty. Prompt subject: a glass tube of neon gas glowing orange on a dark bench.</a:t>
+              <a:t>Section title. PROVISIONAL/OPEN: verbatim DECISIONS title now in the panel. Scope boundary (Matt, 2026-10-04): S2.4 owns what an ion's configuration IS and valence-electron-based charge prediction at the end of the section (main group only). U3.7 and U3.4 own the energetics. PROVISIONAL: group 14 and transition metals are not predicted by the rule here. Not taught here: Lewis dot preview (PROVISIONAL, omitted; belongs to a later unit). Transition-metal valence counting (PROVISIONAL, brief slide 6) also omitted. Image slot empty. Prompt subject: a glass tube of neon gas glowing orange on a dark bench.</a:t>
             </a:r>
             <a:endParaRPr lang="en-US" dirty="0"/>
           </a:p>
@@ -965,7 +965,7 @@
           <a:lstStyle/>
           <a:p>
             <a:r>
-              <a:t>Fe 26, Fe2+ 24 [Ar]3d6, Fe3+ 23 [Ar]3d5. Present 3d5 as an observed electron count, not proof of a cause. Click build replaces the static figure: one slide carries Fe, Fe2+ and Fe3+ (the 4s arrows leave first, then one 3d). The static PNG chem_u02_s2.4_fe_ions_orbitals.png stays on disk for print.</a:t>
+              <a:t>Fe 26, Fe2+ 24 [Ar]3d6, Fe3+ 23 [Ar]3d5. Present 3d5 as an observed electron count, not proof of a cause. Click build replaces the static figure: one slide carries Fe, Fe2+ and Fe3+ (the 4s arrows leave first, then one 3d). Click 3 passes through Fe+ (25 electrons), named on the slide so no species goes unlabelled. The static PNG chem_u02_s2.4_fe_ions_orbitals.png stays on disk for print.</a:t>
             </a:r>
           </a:p>
           <a:p>
@@ -20428,9 +20428,9 @@
         <p:grpSpPr>
           <a:xfrm>
             <a:off x="1024128" y="2761487"/>
-            <a:ext cx="4398264" cy="1097280"/>
+            <a:ext cx="4398264" cy="1024128"/>
             <a:chOff x="1024128" y="2761487"/>
-            <a:chExt cx="4398264" cy="1097280"/>
+            <a:chExt cx="4398264" cy="1024128"/>
           </a:xfrm>
         </p:grpSpPr>
         <p:sp>
@@ -20476,8 +20476,8 @@
           </p:nvSpPr>
           <p:spPr>
             <a:xfrm>
-              <a:off x="1577339" y="3072383"/>
-              <a:ext cx="475488" cy="475488"/>
+              <a:off x="1796795" y="3072383"/>
+              <a:ext cx="402336" cy="402336"/>
             </a:xfrm>
             <a:prstGeom prst="rect">
               <a:avLst/>
@@ -20522,8 +20522,8 @@
           </p:nvSpPr>
           <p:spPr>
             <a:xfrm>
-              <a:off x="1485899" y="3584447"/>
-              <a:ext cx="658368" cy="274320"/>
+              <a:off x="1705355" y="3511295"/>
+              <a:ext cx="585216" cy="274320"/>
             </a:xfrm>
             <a:prstGeom prst="rect">
               <a:avLst/>
@@ -20557,8 +20557,8 @@
           </p:nvSpPr>
           <p:spPr>
             <a:xfrm>
-              <a:off x="2308859" y="3072383"/>
-              <a:ext cx="475488" cy="475488"/>
+              <a:off x="2455163" y="3072383"/>
+              <a:ext cx="402336" cy="402336"/>
             </a:xfrm>
             <a:prstGeom prst="rect">
               <a:avLst/>
@@ -20603,8 +20603,8 @@
           </p:nvSpPr>
           <p:spPr>
             <a:xfrm>
-              <a:off x="2830068" y="3072383"/>
-              <a:ext cx="475488" cy="475488"/>
+              <a:off x="2903220" y="3072383"/>
+              <a:ext cx="402336" cy="402336"/>
             </a:xfrm>
             <a:prstGeom prst="rect">
               <a:avLst/>
@@ -20650,7 +20650,7 @@
           <p:spPr>
             <a:xfrm>
               <a:off x="3351275" y="3072383"/>
-              <a:ext cx="475488" cy="475488"/>
+              <a:ext cx="402336" cy="402336"/>
             </a:xfrm>
             <a:prstGeom prst="rect">
               <a:avLst/>
@@ -20695,8 +20695,8 @@
           </p:nvSpPr>
           <p:spPr>
             <a:xfrm>
-              <a:off x="3872483" y="3072383"/>
-              <a:ext cx="475488" cy="475488"/>
+              <a:off x="3799331" y="3072383"/>
+              <a:ext cx="402336" cy="402336"/>
             </a:xfrm>
             <a:prstGeom prst="rect">
               <a:avLst/>
@@ -20741,8 +20741,8 @@
           </p:nvSpPr>
           <p:spPr>
             <a:xfrm>
-              <a:off x="4393692" y="3072383"/>
-              <a:ext cx="475488" cy="475488"/>
+              <a:off x="4247388" y="3072383"/>
+              <a:ext cx="402336" cy="402336"/>
             </a:xfrm>
             <a:prstGeom prst="rect">
               <a:avLst/>
@@ -20787,8 +20787,8 @@
           </p:nvSpPr>
           <p:spPr>
             <a:xfrm>
-              <a:off x="2217419" y="3584447"/>
-              <a:ext cx="2743200" cy="274320"/>
+              <a:off x="2363723" y="3511295"/>
+              <a:ext cx="2377440" cy="274320"/>
             </a:xfrm>
             <a:prstGeom prst="rect">
               <a:avLst/>
@@ -20823,8 +20823,8 @@
         </p:nvSpPr>
         <p:spPr>
           <a:xfrm>
-            <a:off x="1660550" y="3162726"/>
-            <a:ext cx="118872" cy="294802"/>
+            <a:off x="1867204" y="3148827"/>
+            <a:ext cx="100584" cy="249448"/>
           </a:xfrm>
           <a:prstGeom prst="upArrow">
             <a:avLst>
@@ -20870,8 +20870,8 @@
         </p:nvSpPr>
         <p:spPr>
           <a:xfrm>
-            <a:off x="1850745" y="3162726"/>
-            <a:ext cx="118872" cy="294802"/>
+            <a:off x="2028139" y="3148827"/>
+            <a:ext cx="100584" cy="249448"/>
           </a:xfrm>
           <a:prstGeom prst="downArrow">
             <a:avLst>
@@ -20917,8 +20917,8 @@
         </p:nvSpPr>
         <p:spPr>
           <a:xfrm>
-            <a:off x="2392070" y="3162726"/>
-            <a:ext cx="118872" cy="294802"/>
+            <a:off x="2525572" y="3148827"/>
+            <a:ext cx="100584" cy="249448"/>
           </a:xfrm>
           <a:prstGeom prst="upArrow">
             <a:avLst>
@@ -20964,8 +20964,8 @@
         </p:nvSpPr>
         <p:spPr>
           <a:xfrm>
-            <a:off x="2913278" y="3162726"/>
-            <a:ext cx="118872" cy="294802"/>
+            <a:off x="2973628" y="3148827"/>
+            <a:ext cx="100584" cy="249448"/>
           </a:xfrm>
           <a:prstGeom prst="upArrow">
             <a:avLst>
@@ -21011,8 +21011,8 @@
         </p:nvSpPr>
         <p:spPr>
           <a:xfrm>
-            <a:off x="3434486" y="3162726"/>
-            <a:ext cx="118872" cy="294802"/>
+            <a:off x="3421684" y="3148827"/>
+            <a:ext cx="100584" cy="249448"/>
           </a:xfrm>
           <a:prstGeom prst="upArrow">
             <a:avLst>
@@ -21058,8 +21058,8 @@
         </p:nvSpPr>
         <p:spPr>
           <a:xfrm>
-            <a:off x="3955694" y="3162726"/>
-            <a:ext cx="118872" cy="294802"/>
+            <a:off x="3869740" y="3148827"/>
+            <a:ext cx="100584" cy="249448"/>
           </a:xfrm>
           <a:prstGeom prst="upArrow">
             <a:avLst>
@@ -21105,8 +21105,8 @@
         </p:nvSpPr>
         <p:spPr>
           <a:xfrm>
-            <a:off x="4476902" y="3162726"/>
-            <a:ext cx="118872" cy="294802"/>
+            <a:off x="4317796" y="3148827"/>
+            <a:ext cx="100584" cy="249448"/>
           </a:xfrm>
           <a:prstGeom prst="upArrow">
             <a:avLst>
@@ -21152,8 +21152,8 @@
         </p:nvSpPr>
         <p:spPr>
           <a:xfrm>
-            <a:off x="2582265" y="3162726"/>
-            <a:ext cx="118872" cy="294802"/>
+            <a:off x="2686507" y="3148827"/>
+            <a:ext cx="100584" cy="249448"/>
           </a:xfrm>
           <a:prstGeom prst="downArrow">
             <a:avLst>
@@ -21199,8 +21199,8 @@
         </p:nvSpPr>
         <p:spPr>
           <a:xfrm>
-            <a:off x="1660550" y="3162726"/>
-            <a:ext cx="118872" cy="294802"/>
+            <a:off x="1867204" y="3148827"/>
+            <a:ext cx="100584" cy="249448"/>
           </a:xfrm>
           <a:prstGeom prst="upArrow">
             <a:avLst>
@@ -21248,8 +21248,8 @@
         </p:nvSpPr>
         <p:spPr>
           <a:xfrm>
-            <a:off x="1850745" y="3162726"/>
-            <a:ext cx="118872" cy="294802"/>
+            <a:off x="2028139" y="3148827"/>
+            <a:ext cx="100584" cy="249448"/>
           </a:xfrm>
           <a:prstGeom prst="downArrow">
             <a:avLst>
@@ -21297,8 +21297,8 @@
         </p:nvSpPr>
         <p:spPr>
           <a:xfrm>
-            <a:off x="1024128" y="3895344"/>
-            <a:ext cx="4398264" cy="512064"/>
+            <a:off x="1024128" y="3822191"/>
+            <a:ext cx="4398264" cy="256032"/>
           </a:xfrm>
           <a:prstGeom prst="rect">
             <a:avLst/>
@@ -21319,21 +21319,21 @@
                 </a:solidFill>
                 <a:latin typeface="Trade Gothic Next"/>
               </a:rPr>
-              <a:t>Highest n is 4: the 4s electrons leave first</a:t>
-            </a:r>
-          </a:p>
-        </p:txBody>
-      </p:sp>
-      <p:sp>
-        <p:nvSpPr>
-          <p:cNvPr id="35" name="BUILD caption"/>
+              <a:t>Highest n is 4: 4s leaves first</a:t>
+            </a:r>
+          </a:p>
+        </p:txBody>
+      </p:sp>
+      <p:sp>
+        <p:nvSpPr>
+          <p:cNvPr id="35" name="BUILD state"/>
           <p:cNvSpPr txBox="1"/>
           <p:nvPr/>
         </p:nvSpPr>
         <p:spPr>
           <a:xfrm>
-            <a:off x="1024128" y="4407408"/>
-            <a:ext cx="4398264" cy="256032"/>
+            <a:off x="1024128" y="4114800"/>
+            <a:ext cx="4398264" cy="292608"/>
           </a:xfrm>
           <a:prstGeom prst="rect">
             <a:avLst/>
@@ -21348,13 +21348,13 @@
           <a:p>
             <a:pPr algn="ctr"/>
             <a:r>
-              <a:rPr sz="1600" b="1">
-                <a:solidFill>
-                  <a:srgbClr val="4D730E"/>
+              <a:rPr sz="1800" b="1">
+                <a:solidFill>
+                  <a:srgbClr val="14161B"/>
                 </a:solidFill>
                 <a:latin typeface="Trade Gothic Next"/>
               </a:rPr>
-              <a:t>Then one 3d electron leaves</a:t>
+              <a:t>Fe: charge 0, 26 electrons</a:t>
             </a:r>
           </a:p>
         </p:txBody>
@@ -21367,7 +21367,7 @@
         </p:nvSpPr>
         <p:spPr>
           <a:xfrm>
-            <a:off x="1024128" y="4700016"/>
+            <a:off x="1024128" y="4407408"/>
             <a:ext cx="4398264" cy="292608"/>
           </a:xfrm>
           <a:prstGeom prst="rect">
@@ -21398,6 +21398,59 @@
                 </a:solidFill>
                 <a:latin typeface="Trade Gothic Next"/>
               </a:rPr>
+              <a:t>+</a:t>
+            </a:r>
+            <a:r>
+              <a:rPr sz="1800" b="1">
+                <a:solidFill>
+                  <a:srgbClr val="14161B"/>
+                </a:solidFill>
+                <a:latin typeface="Trade Gothic Next"/>
+              </a:rPr>
+              <a:t>: charge 1+, 25 electrons</a:t>
+            </a:r>
+          </a:p>
+        </p:txBody>
+      </p:sp>
+      <p:sp>
+        <p:nvSpPr>
+          <p:cNvPr id="37" name="BUILD state"/>
+          <p:cNvSpPr txBox="1"/>
+          <p:nvPr/>
+        </p:nvSpPr>
+        <p:spPr>
+          <a:xfrm>
+            <a:off x="1024128" y="4700016"/>
+            <a:ext cx="4398264" cy="292608"/>
+          </a:xfrm>
+          <a:prstGeom prst="rect">
+            <a:avLst/>
+          </a:prstGeom>
+          <a:noFill/>
+        </p:spPr>
+        <p:txBody>
+          <a:bodyPr wrap="square" lIns="0" rIns="0" tIns="0" bIns="0" anchor="ctr">
+            <a:spAutoFit/>
+          </a:bodyPr>
+          <a:lstStyle/>
+          <a:p>
+            <a:pPr algn="ctr"/>
+            <a:r>
+              <a:rPr sz="1800" b="1">
+                <a:solidFill>
+                  <a:srgbClr val="14161B"/>
+                </a:solidFill>
+                <a:latin typeface="Trade Gothic Next"/>
+              </a:rPr>
+              <a:t>Fe</a:t>
+            </a:r>
+            <a:r>
+              <a:rPr sz="1800" b="1" baseline="30000">
+                <a:solidFill>
+                  <a:srgbClr val="14161B"/>
+                </a:solidFill>
+                <a:latin typeface="Trade Gothic Next"/>
+              </a:rPr>
               <a:t>2+</a:t>
             </a:r>
             <a:r>
@@ -21414,7 +21467,7 @@
       </p:sp>
       <p:sp>
         <p:nvSpPr>
-          <p:cNvPr id="37" name="BUILD state"/>
+          <p:cNvPr id="38" name="BUILD state"/>
           <p:cNvSpPr txBox="1"/>
           <p:nvPr/>
         </p:nvSpPr>
@@ -22147,6 +22200,41 @@
                                   </p:childTnLst>
                                 </p:cTn>
                               </p:par>
+                              <p:par>
+                                <p:cTn id="41" presetID="10" presetClass="entr" presetSubtype="0" fill="hold" grpId="0" nodeType="withEffect">
+                                  <p:stCondLst>
+                                    <p:cond delay="0"/>
+                                  </p:stCondLst>
+                                  <p:childTnLst>
+                                    <p:set>
+                                      <p:cBhvr>
+                                        <p:cTn id="42" dur="1" fill="hold">
+                                          <p:stCondLst>
+                                            <p:cond delay="0"/>
+                                          </p:stCondLst>
+                                        </p:cTn>
+                                        <p:tgtEl>
+                                          <p:spTgt spid="35"/>
+                                        </p:tgtEl>
+                                        <p:attrNameLst>
+                                          <p:attrName>style.visibility</p:attrName>
+                                        </p:attrNameLst>
+                                      </p:cBhvr>
+                                      <p:to>
+                                        <p:strVal val="visible"/>
+                                      </p:to>
+                                    </p:set>
+                                    <p:animEffect transition="in" filter="fade">
+                                      <p:cBhvr>
+                                        <p:cTn id="43" dur="400"/>
+                                        <p:tgtEl>
+                                          <p:spTgt spid="35"/>
+                                        </p:tgtEl>
+                                      </p:cBhvr>
+                                    </p:animEffect>
+                                  </p:childTnLst>
+                                </p:cTn>
+                              </p:par>
                             </p:childTnLst>
                           </p:cTn>
                         </p:par>
@@ -22154,26 +22242,26 @@
                     </p:cTn>
                   </p:par>
                   <p:par>
-                    <p:cTn id="41" fill="hold">
+                    <p:cTn id="44" fill="hold">
                       <p:stCondLst>
                         <p:cond delay="indefinite"/>
                       </p:stCondLst>
                       <p:childTnLst>
                         <p:par>
-                          <p:cTn id="42" fill="hold">
+                          <p:cTn id="45" fill="hold">
                             <p:stCondLst>
                               <p:cond delay="0"/>
                             </p:stCondLst>
                             <p:childTnLst>
                               <p:par>
-                                <p:cTn id="43" presetID="10" presetClass="entr" presetSubtype="0" fill="hold" grpId="0" nodeType="clickEffect">
+                                <p:cTn id="46" presetID="10" presetClass="entr" presetSubtype="0" fill="hold" grpId="0" nodeType="clickEffect">
                                   <p:stCondLst>
                                     <p:cond delay="0"/>
                                   </p:stCondLst>
                                   <p:childTnLst>
                                     <p:set>
                                       <p:cBhvr>
-                                        <p:cTn id="44" dur="1" fill="hold">
+                                        <p:cTn id="47" dur="1" fill="hold">
                                           <p:stCondLst>
                                             <p:cond delay="0"/>
                                           </p:stCondLst>
@@ -22191,44 +22279,9 @@
                                     </p:set>
                                     <p:animEffect transition="in" filter="fade">
                                       <p:cBhvr>
-                                        <p:cTn id="45" dur="400"/>
+                                        <p:cTn id="48" dur="400"/>
                                         <p:tgtEl>
                                           <p:spTgt spid="32"/>
-                                        </p:tgtEl>
-                                      </p:cBhvr>
-                                    </p:animEffect>
-                                  </p:childTnLst>
-                                </p:cTn>
-                              </p:par>
-                              <p:par>
-                                <p:cTn id="46" presetID="10" presetClass="entr" presetSubtype="0" fill="hold" grpId="0" nodeType="withEffect">
-                                  <p:stCondLst>
-                                    <p:cond delay="0"/>
-                                  </p:stCondLst>
-                                  <p:childTnLst>
-                                    <p:set>
-                                      <p:cBhvr>
-                                        <p:cTn id="47" dur="1" fill="hold">
-                                          <p:stCondLst>
-                                            <p:cond delay="0"/>
-                                          </p:stCondLst>
-                                        </p:cTn>
-                                        <p:tgtEl>
-                                          <p:spTgt spid="33"/>
-                                        </p:tgtEl>
-                                        <p:attrNameLst>
-                                          <p:attrName>style.visibility</p:attrName>
-                                        </p:attrNameLst>
-                                      </p:cBhvr>
-                                      <p:to>
-                                        <p:strVal val="visible"/>
-                                      </p:to>
-                                    </p:set>
-                                    <p:animEffect transition="in" filter="fade">
-                                      <p:cBhvr>
-                                        <p:cTn id="48" dur="400"/>
-                                        <p:tgtEl>
-                                          <p:spTgt spid="33"/>
                                         </p:tgtEl>
                                       </p:cBhvr>
                                     </p:animEffect>
@@ -22249,6 +22302,41 @@
                                           </p:stCondLst>
                                         </p:cTn>
                                         <p:tgtEl>
+                                          <p:spTgt spid="33"/>
+                                        </p:tgtEl>
+                                        <p:attrNameLst>
+                                          <p:attrName>style.visibility</p:attrName>
+                                        </p:attrNameLst>
+                                      </p:cBhvr>
+                                      <p:to>
+                                        <p:strVal val="visible"/>
+                                      </p:to>
+                                    </p:set>
+                                    <p:animEffect transition="in" filter="fade">
+                                      <p:cBhvr>
+                                        <p:cTn id="51" dur="400"/>
+                                        <p:tgtEl>
+                                          <p:spTgt spid="33"/>
+                                        </p:tgtEl>
+                                      </p:cBhvr>
+                                    </p:animEffect>
+                                  </p:childTnLst>
+                                </p:cTn>
+                              </p:par>
+                              <p:par>
+                                <p:cTn id="52" presetID="10" presetClass="entr" presetSubtype="0" fill="hold" grpId="0" nodeType="withEffect">
+                                  <p:stCondLst>
+                                    <p:cond delay="0"/>
+                                  </p:stCondLst>
+                                  <p:childTnLst>
+                                    <p:set>
+                                      <p:cBhvr>
+                                        <p:cTn id="53" dur="1" fill="hold">
+                                          <p:stCondLst>
+                                            <p:cond delay="0"/>
+                                          </p:stCondLst>
+                                        </p:cTn>
+                                        <p:tgtEl>
                                           <p:spTgt spid="34"/>
                                         </p:tgtEl>
                                         <p:attrNameLst>
@@ -22261,7 +22349,7 @@
                                     </p:set>
                                     <p:animEffect transition="in" filter="fade">
                                       <p:cBhvr>
-                                        <p:cTn id="51" dur="400"/>
+                                        <p:cTn id="54" dur="400"/>
                                         <p:tgtEl>
                                           <p:spTgt spid="34"/>
                                         </p:tgtEl>
@@ -22277,26 +22365,26 @@
                     </p:cTn>
                   </p:par>
                   <p:par>
-                    <p:cTn id="52" fill="hold">
+                    <p:cTn id="55" fill="hold">
                       <p:stCondLst>
                         <p:cond delay="indefinite"/>
                       </p:stCondLst>
                       <p:childTnLst>
                         <p:par>
-                          <p:cTn id="53" fill="hold">
+                          <p:cTn id="56" fill="hold">
                             <p:stCondLst>
                               <p:cond delay="0"/>
                             </p:stCondLst>
                             <p:childTnLst>
                               <p:par>
-                                <p:cTn id="54" presetID="10" presetClass="exit" presetSubtype="0" fill="hold" grpId="0" nodeType="clickEffect">
+                                <p:cTn id="57" presetID="10" presetClass="exit" presetSubtype="0" fill="hold" grpId="0" nodeType="clickEffect">
                                   <p:stCondLst>
                                     <p:cond delay="0"/>
                                   </p:stCondLst>
                                   <p:childTnLst>
                                     <p:animEffect transition="out" filter="fade">
                                       <p:cBhvr>
-                                        <p:cTn id="55" dur="400"/>
+                                        <p:cTn id="58" dur="400"/>
                                         <p:tgtEl>
                                           <p:spTgt spid="25"/>
                                         </p:tgtEl>
@@ -22304,7 +22392,7 @@
                                     </p:animEffect>
                                     <p:set>
                                       <p:cBhvr>
-                                        <p:cTn id="56" dur="1" fill="hold">
+                                        <p:cTn id="59" dur="1" fill="hold">
                                           <p:stCondLst>
                                             <p:cond delay="399"/>
                                           </p:stCondLst>
@@ -22324,14 +22412,14 @@
                                 </p:cTn>
                               </p:par>
                               <p:par>
-                                <p:cTn id="57" presetID="10" presetClass="exit" presetSubtype="0" fill="hold" grpId="0" nodeType="withEffect">
+                                <p:cTn id="60" presetID="10" presetClass="exit" presetSubtype="0" fill="hold" grpId="0" nodeType="withEffect">
                                   <p:stCondLst>
                                     <p:cond delay="0"/>
                                   </p:stCondLst>
                                   <p:childTnLst>
                                     <p:animEffect transition="out" filter="fade">
                                       <p:cBhvr>
-                                        <p:cTn id="58" dur="400"/>
+                                        <p:cTn id="61" dur="400"/>
                                         <p:tgtEl>
                                           <p:spTgt spid="33"/>
                                         </p:tgtEl>
@@ -22339,7 +22427,7 @@
                                     </p:animEffect>
                                     <p:set>
                                       <p:cBhvr>
-                                        <p:cTn id="59" dur="1" fill="hold">
+                                        <p:cTn id="62" dur="1" fill="hold">
                                           <p:stCondLst>
                                             <p:cond delay="399"/>
                                           </p:stCondLst>
@@ -22358,6 +22446,41 @@
                                   </p:childTnLst>
                                 </p:cTn>
                               </p:par>
+                              <p:par>
+                                <p:cTn id="63" presetID="10" presetClass="entr" presetSubtype="0" fill="hold" grpId="0" nodeType="withEffect">
+                                  <p:stCondLst>
+                                    <p:cond delay="0"/>
+                                  </p:stCondLst>
+                                  <p:childTnLst>
+                                    <p:set>
+                                      <p:cBhvr>
+                                        <p:cTn id="64" dur="1" fill="hold">
+                                          <p:stCondLst>
+                                            <p:cond delay="0"/>
+                                          </p:stCondLst>
+                                        </p:cTn>
+                                        <p:tgtEl>
+                                          <p:spTgt spid="36"/>
+                                        </p:tgtEl>
+                                        <p:attrNameLst>
+                                          <p:attrName>style.visibility</p:attrName>
+                                        </p:attrNameLst>
+                                      </p:cBhvr>
+                                      <p:to>
+                                        <p:strVal val="visible"/>
+                                      </p:to>
+                                    </p:set>
+                                    <p:animEffect transition="in" filter="fade">
+                                      <p:cBhvr>
+                                        <p:cTn id="65" dur="400"/>
+                                        <p:tgtEl>
+                                          <p:spTgt spid="36"/>
+                                        </p:tgtEl>
+                                      </p:cBhvr>
+                                    </p:animEffect>
+                                  </p:childTnLst>
+                                </p:cTn>
+                              </p:par>
                             </p:childTnLst>
                           </p:cTn>
                         </p:par>
@@ -22365,26 +22488,26 @@
                     </p:cTn>
                   </p:par>
                   <p:par>
-                    <p:cTn id="60" fill="hold">
+                    <p:cTn id="66" fill="hold">
                       <p:stCondLst>
                         <p:cond delay="indefinite"/>
                       </p:stCondLst>
                       <p:childTnLst>
                         <p:par>
-                          <p:cTn id="61" fill="hold">
+                          <p:cTn id="67" fill="hold">
                             <p:stCondLst>
                               <p:cond delay="0"/>
                             </p:stCondLst>
                             <p:childTnLst>
                               <p:par>
-                                <p:cTn id="62" presetID="10" presetClass="exit" presetSubtype="0" fill="hold" grpId="0" nodeType="clickEffect">
+                                <p:cTn id="68" presetID="10" presetClass="exit" presetSubtype="0" fill="hold" grpId="0" nodeType="clickEffect">
                                   <p:stCondLst>
                                     <p:cond delay="0"/>
                                   </p:stCondLst>
                                   <p:childTnLst>
                                     <p:animEffect transition="out" filter="fade">
                                       <p:cBhvr>
-                                        <p:cTn id="63" dur="400"/>
+                                        <p:cTn id="69" dur="400"/>
                                         <p:tgtEl>
                                           <p:spTgt spid="24"/>
                                         </p:tgtEl>
@@ -22392,7 +22515,7 @@
                                     </p:animEffect>
                                     <p:set>
                                       <p:cBhvr>
-                                        <p:cTn id="64" dur="1" fill="hold">
+                                        <p:cTn id="70" dur="1" fill="hold">
                                           <p:stCondLst>
                                             <p:cond delay="399"/>
                                           </p:stCondLst>
@@ -22412,14 +22535,14 @@
                                 </p:cTn>
                               </p:par>
                               <p:par>
-                                <p:cTn id="65" presetID="10" presetClass="exit" presetSubtype="0" fill="hold" grpId="0" nodeType="withEffect">
+                                <p:cTn id="71" presetID="10" presetClass="exit" presetSubtype="0" fill="hold" grpId="0" nodeType="withEffect">
                                   <p:stCondLst>
                                     <p:cond delay="0"/>
                                   </p:stCondLst>
                                   <p:childTnLst>
                                     <p:animEffect transition="out" filter="fade">
                                       <p:cBhvr>
-                                        <p:cTn id="66" dur="400"/>
+                                        <p:cTn id="72" dur="400"/>
                                         <p:tgtEl>
                                           <p:spTgt spid="32"/>
                                         </p:tgtEl>
@@ -22427,7 +22550,7 @@
                                     </p:animEffect>
                                     <p:set>
                                       <p:cBhvr>
-                                        <p:cTn id="67" dur="1" fill="hold">
+                                        <p:cTn id="73" dur="1" fill="hold">
                                           <p:stCondLst>
                                             <p:cond delay="399"/>
                                           </p:stCondLst>
@@ -22447,20 +22570,20 @@
                                 </p:cTn>
                               </p:par>
                               <p:par>
-                                <p:cTn id="68" presetID="10" presetClass="entr" presetSubtype="0" fill="hold" grpId="0" nodeType="withEffect">
+                                <p:cTn id="74" presetID="10" presetClass="entr" presetSubtype="0" fill="hold" grpId="0" nodeType="withEffect">
                                   <p:stCondLst>
                                     <p:cond delay="0"/>
                                   </p:stCondLst>
                                   <p:childTnLst>
                                     <p:set>
                                       <p:cBhvr>
-                                        <p:cTn id="69" dur="1" fill="hold">
+                                        <p:cTn id="75" dur="1" fill="hold">
                                           <p:stCondLst>
                                             <p:cond delay="0"/>
                                           </p:stCondLst>
                                         </p:cTn>
                                         <p:tgtEl>
-                                          <p:spTgt spid="36"/>
+                                          <p:spTgt spid="37"/>
                                         </p:tgtEl>
                                         <p:attrNameLst>
                                           <p:attrName>style.visibility</p:attrName>
@@ -22472,9 +22595,9 @@
                                     </p:set>
                                     <p:animEffect transition="in" filter="fade">
                                       <p:cBhvr>
-                                        <p:cTn id="70" dur="400"/>
+                                        <p:cTn id="76" dur="400"/>
                                         <p:tgtEl>
-                                          <p:spTgt spid="36"/>
+                                          <p:spTgt spid="37"/>
                                         </p:tgtEl>
                                       </p:cBhvr>
                                     </p:animEffect>
@@ -22488,26 +22611,26 @@
                     </p:cTn>
                   </p:par>
                   <p:par>
-                    <p:cTn id="71" fill="hold">
+                    <p:cTn id="77" fill="hold">
                       <p:stCondLst>
                         <p:cond delay="indefinite"/>
                       </p:stCondLst>
                       <p:childTnLst>
                         <p:par>
-                          <p:cTn id="72" fill="hold">
+                          <p:cTn id="78" fill="hold">
                             <p:stCondLst>
                               <p:cond delay="0"/>
                             </p:stCondLst>
                             <p:childTnLst>
                               <p:par>
-                                <p:cTn id="73" presetID="10" presetClass="exit" presetSubtype="0" fill="hold" grpId="0" nodeType="clickEffect">
+                                <p:cTn id="79" presetID="10" presetClass="exit" presetSubtype="0" fill="hold" grpId="0" nodeType="clickEffect">
                                   <p:stCondLst>
                                     <p:cond delay="0"/>
                                   </p:stCondLst>
                                   <p:childTnLst>
                                     <p:animEffect transition="out" filter="fade">
                                       <p:cBhvr>
-                                        <p:cTn id="74" dur="400"/>
+                                        <p:cTn id="80" dur="400"/>
                                         <p:tgtEl>
                                           <p:spTgt spid="31"/>
                                         </p:tgtEl>
@@ -22515,7 +22638,7 @@
                                     </p:animEffect>
                                     <p:set>
                                       <p:cBhvr>
-                                        <p:cTn id="75" dur="1" fill="hold">
+                                        <p:cTn id="81" dur="1" fill="hold">
                                           <p:stCondLst>
                                             <p:cond delay="399"/>
                                           </p:stCondLst>
@@ -22535,20 +22658,20 @@
                                 </p:cTn>
                               </p:par>
                               <p:par>
-                                <p:cTn id="76" presetID="10" presetClass="entr" presetSubtype="0" fill="hold" grpId="0" nodeType="withEffect">
+                                <p:cTn id="82" presetID="10" presetClass="entr" presetSubtype="0" fill="hold" grpId="0" nodeType="withEffect">
                                   <p:stCondLst>
                                     <p:cond delay="0"/>
                                   </p:stCondLst>
                                   <p:childTnLst>
                                     <p:set>
                                       <p:cBhvr>
-                                        <p:cTn id="77" dur="1" fill="hold">
+                                        <p:cTn id="83" dur="1" fill="hold">
                                           <p:stCondLst>
                                             <p:cond delay="0"/>
                                           </p:stCondLst>
                                         </p:cTn>
                                         <p:tgtEl>
-                                          <p:spTgt spid="35"/>
+                                          <p:spTgt spid="38"/>
                                         </p:tgtEl>
                                         <p:attrNameLst>
                                           <p:attrName>style.visibility</p:attrName>
@@ -22560,44 +22683,9 @@
                                     </p:set>
                                     <p:animEffect transition="in" filter="fade">
                                       <p:cBhvr>
-                                        <p:cTn id="78" dur="400"/>
+                                        <p:cTn id="84" dur="400"/>
                                         <p:tgtEl>
-                                          <p:spTgt spid="35"/>
-                                        </p:tgtEl>
-                                      </p:cBhvr>
-                                    </p:animEffect>
-                                  </p:childTnLst>
-                                </p:cTn>
-                              </p:par>
-                              <p:par>
-                                <p:cTn id="79" presetID="10" presetClass="entr" presetSubtype="0" fill="hold" grpId="0" nodeType="withEffect">
-                                  <p:stCondLst>
-                                    <p:cond delay="0"/>
-                                  </p:stCondLst>
-                                  <p:childTnLst>
-                                    <p:set>
-                                      <p:cBhvr>
-                                        <p:cTn id="80" dur="1" fill="hold">
-                                          <p:stCondLst>
-                                            <p:cond delay="0"/>
-                                          </p:stCondLst>
-                                        </p:cTn>
-                                        <p:tgtEl>
-                                          <p:spTgt spid="37"/>
-                                        </p:tgtEl>
-                                        <p:attrNameLst>
-                                          <p:attrName>style.visibility</p:attrName>
-                                        </p:attrNameLst>
-                                      </p:cBhvr>
-                                      <p:to>
-                                        <p:strVal val="visible"/>
-                                      </p:to>
-                                    </p:set>
-                                    <p:animEffect transition="in" filter="fade">
-                                      <p:cBhvr>
-                                        <p:cTn id="81" dur="400"/>
-                                        <p:tgtEl>
-                                          <p:spTgt spid="37"/>
+                                          <p:spTgt spid="38"/>
                                         </p:tgtEl>
                                       </p:cBhvr>
                                     </p:animEffect>
@@ -22640,12 +22728,13 @@
       <p:bldP spid="29" grpId="0" animBg="1"/>
       <p:bldP spid="30" grpId="0" animBg="1"/>
       <p:bldP spid="31" grpId="0" animBg="1"/>
+      <p:bldP spid="35" grpId="0"/>
       <p:bldP spid="32" grpId="0" animBg="1"/>
       <p:bldP spid="33" grpId="0" animBg="1"/>
       <p:bldP spid="34" grpId="0"/>
       <p:bldP spid="36" grpId="0"/>
-      <p:bldP spid="35" grpId="0"/>
       <p:bldP spid="37" grpId="0"/>
+      <p:bldP spid="38" grpId="0"/>
     </p:bldLst>
   </p:timing>
 </p:sld>
@@ -28829,7 +28918,119 @@
                 <a:ea typeface="Trade Gothic Next" pitchFamily="34" charset="-122"/>
                 <a:cs typeface="Trade Gothic Next" pitchFamily="34" charset="-120"/>
               </a:rPr>
-              <a:t>Mg 2+, Al 3+, S 2−, Br 1−. Each move ends at a noble gas configuration.</a:t>
+              <a:t>Mg</a:t>
+            </a:r>
+            <a:pPr indent="0" marL="0">
+              <a:buNone/>
+            </a:pPr>
+            <a:r>
+              <a:rPr lang="en-US" sz="1600" b="1" baseline="30000" dirty="0">
+                <a:solidFill>
+                  <a:srgbClr val="EDF0E5"/>
+                </a:solidFill>
+                <a:latin typeface="Trade Gothic Next" pitchFamily="34" charset="0"/>
+                <a:ea typeface="Trade Gothic Next" pitchFamily="34" charset="-122"/>
+                <a:cs typeface="Trade Gothic Next" pitchFamily="34" charset="-120"/>
+              </a:rPr>
+              <a:t>2+</a:t>
+            </a:r>
+            <a:pPr indent="0" marL="0">
+              <a:buNone/>
+            </a:pPr>
+            <a:r>
+              <a:rPr lang="en-US" sz="1600" b="1" dirty="0">
+                <a:solidFill>
+                  <a:srgbClr val="EDF0E5"/>
+                </a:solidFill>
+                <a:latin typeface="Trade Gothic Next" pitchFamily="34" charset="0"/>
+                <a:ea typeface="Trade Gothic Next" pitchFamily="34" charset="-122"/>
+                <a:cs typeface="Trade Gothic Next" pitchFamily="34" charset="-120"/>
+              </a:rPr>
+              <a:t>, Al</a:t>
+            </a:r>
+            <a:pPr indent="0" marL="0">
+              <a:buNone/>
+            </a:pPr>
+            <a:r>
+              <a:rPr lang="en-US" sz="1600" b="1" baseline="30000" dirty="0">
+                <a:solidFill>
+                  <a:srgbClr val="EDF0E5"/>
+                </a:solidFill>
+                <a:latin typeface="Trade Gothic Next" pitchFamily="34" charset="0"/>
+                <a:ea typeface="Trade Gothic Next" pitchFamily="34" charset="-122"/>
+                <a:cs typeface="Trade Gothic Next" pitchFamily="34" charset="-120"/>
+              </a:rPr>
+              <a:t>3+</a:t>
+            </a:r>
+            <a:pPr indent="0" marL="0">
+              <a:buNone/>
+            </a:pPr>
+            <a:r>
+              <a:rPr lang="en-US" sz="1600" b="1" dirty="0">
+                <a:solidFill>
+                  <a:srgbClr val="EDF0E5"/>
+                </a:solidFill>
+                <a:latin typeface="Trade Gothic Next" pitchFamily="34" charset="0"/>
+                <a:ea typeface="Trade Gothic Next" pitchFamily="34" charset="-122"/>
+                <a:cs typeface="Trade Gothic Next" pitchFamily="34" charset="-120"/>
+              </a:rPr>
+              <a:t>, S</a:t>
+            </a:r>
+            <a:pPr indent="0" marL="0">
+              <a:buNone/>
+            </a:pPr>
+            <a:r>
+              <a:rPr lang="en-US" sz="1600" b="1" baseline="30000" dirty="0">
+                <a:solidFill>
+                  <a:srgbClr val="EDF0E5"/>
+                </a:solidFill>
+                <a:latin typeface="Trade Gothic Next" pitchFamily="34" charset="0"/>
+                <a:ea typeface="Trade Gothic Next" pitchFamily="34" charset="-122"/>
+                <a:cs typeface="Trade Gothic Next" pitchFamily="34" charset="-120"/>
+              </a:rPr>
+              <a:t>2−</a:t>
+            </a:r>
+            <a:pPr indent="0" marL="0">
+              <a:buNone/>
+            </a:pPr>
+            <a:r>
+              <a:rPr lang="en-US" sz="1600" b="1" dirty="0">
+                <a:solidFill>
+                  <a:srgbClr val="EDF0E5"/>
+                </a:solidFill>
+                <a:latin typeface="Trade Gothic Next" pitchFamily="34" charset="0"/>
+                <a:ea typeface="Trade Gothic Next" pitchFamily="34" charset="-122"/>
+                <a:cs typeface="Trade Gothic Next" pitchFamily="34" charset="-120"/>
+              </a:rPr>
+              <a:t>, Br</a:t>
+            </a:r>
+            <a:pPr indent="0" marL="0">
+              <a:buNone/>
+            </a:pPr>
+            <a:r>
+              <a:rPr lang="en-US" sz="1600" b="1" baseline="30000" dirty="0">
+                <a:solidFill>
+                  <a:srgbClr val="EDF0E5"/>
+                </a:solidFill>
+                <a:latin typeface="Trade Gothic Next" pitchFamily="34" charset="0"/>
+                <a:ea typeface="Trade Gothic Next" pitchFamily="34" charset="-122"/>
+                <a:cs typeface="Trade Gothic Next" pitchFamily="34" charset="-120"/>
+              </a:rPr>
+              <a:t>−</a:t>
+            </a:r>
+            <a:pPr indent="0" marL="0">
+              <a:buNone/>
+            </a:pPr>
+            <a:r>
+              <a:rPr lang="en-US" sz="1600" b="1" dirty="0">
+                <a:solidFill>
+                  <a:srgbClr val="EDF0E5"/>
+                </a:solidFill>
+                <a:latin typeface="Trade Gothic Next" pitchFamily="34" charset="0"/>
+                <a:ea typeface="Trade Gothic Next" pitchFamily="34" charset="-122"/>
+                <a:cs typeface="Trade Gothic Next" pitchFamily="34" charset="-120"/>
+              </a:rPr>
+              <a:t>. Each move ends at a noble gas configuration.</a:t>
             </a:r>
             <a:endParaRPr lang="en-US" sz="1600" dirty="0"/>
           </a:p>
@@ -30330,15 +30531,68 @@
                                   </p:childTnLst>
                                 </p:cTn>
                               </p:par>
+                            </p:childTnLst>
+                          </p:cTn>
+                        </p:par>
+                      </p:childTnLst>
+                    </p:cTn>
+                  </p:par>
+                  <p:par>
+                    <p:cTn id="38" fill="hold">
+                      <p:stCondLst>
+                        <p:cond delay="indefinite"/>
+                      </p:stCondLst>
+                      <p:childTnLst>
+                        <p:par>
+                          <p:cTn id="39" fill="hold">
+                            <p:stCondLst>
+                              <p:cond delay="0"/>
+                            </p:stCondLst>
+                            <p:childTnLst>
                               <p:par>
-                                <p:cTn id="38" presetID="10" presetClass="entr" presetSubtype="0" fill="hold" grpId="0" nodeType="withEffect">
+                                <p:cTn id="40" presetID="10" presetClass="entr" presetSubtype="0" fill="hold" grpId="0" nodeType="clickEffect">
                                   <p:stCondLst>
                                     <p:cond delay="0"/>
                                   </p:stCondLst>
                                   <p:childTnLst>
                                     <p:set>
                                       <p:cBhvr>
-                                        <p:cTn id="39" dur="1" fill="hold">
+                                        <p:cTn id="41" dur="1" fill="hold">
+                                          <p:stCondLst>
+                                            <p:cond delay="0"/>
+                                          </p:stCondLst>
+                                        </p:cTn>
+                                        <p:tgtEl>
+                                          <p:spTgt spid="27"/>
+                                        </p:tgtEl>
+                                        <p:attrNameLst>
+                                          <p:attrName>style.visibility</p:attrName>
+                                        </p:attrNameLst>
+                                      </p:cBhvr>
+                                      <p:to>
+                                        <p:strVal val="visible"/>
+                                      </p:to>
+                                    </p:set>
+                                    <p:animEffect transition="in" filter="fade">
+                                      <p:cBhvr>
+                                        <p:cTn id="42" dur="400"/>
+                                        <p:tgtEl>
+                                          <p:spTgt spid="27"/>
+                                        </p:tgtEl>
+                                      </p:cBhvr>
+                                    </p:animEffect>
+                                  </p:childTnLst>
+                                </p:cTn>
+                              </p:par>
+                              <p:par>
+                                <p:cTn id="43" presetID="10" presetClass="entr" presetSubtype="0" fill="hold" grpId="0" nodeType="withEffect">
+                                  <p:stCondLst>
+                                    <p:cond delay="0"/>
+                                  </p:stCondLst>
+                                  <p:childTnLst>
+                                    <p:set>
+                                      <p:cBhvr>
+                                        <p:cTn id="44" dur="1" fill="hold">
                                           <p:stCondLst>
                                             <p:cond delay="0"/>
                                           </p:stCondLst>
@@ -30356,62 +30610,9 @@
                                     </p:set>
                                     <p:animEffect transition="in" filter="fade">
                                       <p:cBhvr>
-                                        <p:cTn id="40" dur="400"/>
+                                        <p:cTn id="45" dur="400"/>
                                         <p:tgtEl>
                                           <p:spTgt spid="28"/>
-                                        </p:tgtEl>
-                                      </p:cBhvr>
-                                    </p:animEffect>
-                                  </p:childTnLst>
-                                </p:cTn>
-                              </p:par>
-                            </p:childTnLst>
-                          </p:cTn>
-                        </p:par>
-                      </p:childTnLst>
-                    </p:cTn>
-                  </p:par>
-                  <p:par>
-                    <p:cTn id="41" fill="hold">
-                      <p:stCondLst>
-                        <p:cond delay="indefinite"/>
-                      </p:stCondLst>
-                      <p:childTnLst>
-                        <p:par>
-                          <p:cTn id="42" fill="hold">
-                            <p:stCondLst>
-                              <p:cond delay="0"/>
-                            </p:stCondLst>
-                            <p:childTnLst>
-                              <p:par>
-                                <p:cTn id="43" presetID="10" presetClass="entr" presetSubtype="0" fill="hold" grpId="0" nodeType="clickEffect">
-                                  <p:stCondLst>
-                                    <p:cond delay="0"/>
-                                  </p:stCondLst>
-                                  <p:childTnLst>
-                                    <p:set>
-                                      <p:cBhvr>
-                                        <p:cTn id="44" dur="1" fill="hold">
-                                          <p:stCondLst>
-                                            <p:cond delay="0"/>
-                                          </p:stCondLst>
-                                        </p:cTn>
-                                        <p:tgtEl>
-                                          <p:spTgt spid="27"/>
-                                        </p:tgtEl>
-                                        <p:attrNameLst>
-                                          <p:attrName>style.visibility</p:attrName>
-                                        </p:attrNameLst>
-                                      </p:cBhvr>
-                                      <p:to>
-                                        <p:strVal val="visible"/>
-                                      </p:to>
-                                    </p:set>
-                                    <p:animEffect transition="in" filter="fade">
-                                      <p:cBhvr>
-                                        <p:cTn id="45" dur="400"/>
-                                        <p:tgtEl>
-                                          <p:spTgt spid="27"/>
                                         </p:tgtEl>
                                       </p:cBhvr>
                                     </p:animEffect>
@@ -30488,8 +30689,8 @@
       <p:bldP spid="24" grpId="0" animBg="1"/>
       <p:bldP spid="25" grpId="0" animBg="1"/>
       <p:bldP spid="26" grpId="0" animBg="1"/>
+      <p:bldP spid="27" grpId="0" animBg="1"/>
       <p:bldP spid="28" grpId="0"/>
-      <p:bldP spid="27" grpId="0" animBg="1"/>
       <p:bldP spid="29" grpId="0"/>
     </p:bldLst>
   </p:timing>

</xml_diff>